<commit_message>
Evaluations: Add support for printing/exporting using PowerPoint or the internal table templates
</commit_message>
<xml_diff>
--- a/resources/assets/files/evaluations/SpeakingEvaluationTemplate-Full.pptx
+++ b/resources/assets/files/evaluations/SpeakingEvaluationTemplate-Full.pptx
@@ -11,12 +11,13 @@
   <p:notesSz cx="7315200" cy="9601200"/>
   <p:embeddedFontLst>
     <p:embeddedFont>
-      <p:font typeface="Just Another Hand" panose="02000506000000020003" pitchFamily="2" charset="0"/>
+      <p:font typeface="Kakao Big Sans" panose="00000500000000000000" pitchFamily="2" charset="0"/>
       <p:regular r:id="rId3"/>
     </p:embeddedFont>
     <p:embeddedFont>
-      <p:font typeface="Kakao Big Sans" panose="00000500000000000000" pitchFamily="2" charset="0"/>
-      <p:regular r:id="rId4"/>
+      <p:font typeface="Segoe UI Semibold" panose="020B0702040204020203" pitchFamily="34" charset="0"/>
+      <p:bold r:id="rId4"/>
+      <p:boldItalic r:id="rId5"/>
     </p:embeddedFont>
   </p:embeddedFontLst>
   <p:defaultTextStyle>
@@ -140,414 +141,6 @@
     </p:ext>
   </p:extLst>
 </p:presentation>
-</file>
-
-<file path=ppt/changesInfos/changesInfo1.xml><?xml version="1.0" encoding="utf-8"?>
-<pc:chgInfo xmlns:a="http://schemas.openxmlformats.org/drawingml/2006/main" xmlns:r="http://schemas.openxmlformats.org/officeDocument/2006/relationships" xmlns:ac="http://schemas.microsoft.com/office/drawing/2013/main/command" xmlns:pc="http://schemas.microsoft.com/office/powerpoint/2013/main/command">
-  <pc:docChgLst>
-    <pc:chgData name="Warren Feltmate" userId="06ccb0c333b4239d" providerId="LiveId" clId="{6D720346-0215-4FDF-AA29-99E925BD0FD7}"/>
-    <pc:docChg chg="modSld">
-      <pc:chgData name="Warren Feltmate" userId="06ccb0c333b4239d" providerId="LiveId" clId="{6D720346-0215-4FDF-AA29-99E925BD0FD7}" dt="2025-06-22T11:57:03.048" v="2" actId="20577"/>
-      <pc:docMkLst>
-        <pc:docMk/>
-      </pc:docMkLst>
-      <pc:sldChg chg="modSp mod">
-        <pc:chgData name="Warren Feltmate" userId="06ccb0c333b4239d" providerId="LiveId" clId="{6D720346-0215-4FDF-AA29-99E925BD0FD7}" dt="2025-06-22T11:57:03.048" v="2" actId="20577"/>
-        <pc:sldMkLst>
-          <pc:docMk/>
-          <pc:sldMk cId="2986033172" sldId="258"/>
-        </pc:sldMkLst>
-        <pc:spChg chg="mod">
-          <ac:chgData name="Warren Feltmate" userId="06ccb0c333b4239d" providerId="LiveId" clId="{6D720346-0215-4FDF-AA29-99E925BD0FD7}" dt="2025-06-22T11:57:03.048" v="2" actId="20577"/>
-          <ac:spMkLst>
-            <pc:docMk/>
-            <pc:sldMk cId="2986033172" sldId="258"/>
-            <ac:spMk id="8" creationId="{EEE46E5F-FB90-FABC-4D3B-8E8E26233BC6}"/>
-          </ac:spMkLst>
-        </pc:spChg>
-      </pc:sldChg>
-    </pc:docChg>
-  </pc:docChgLst>
-  <pc:docChgLst>
-    <pc:chgData name="Warren Feltmate" userId="06ccb0c333b4239d" providerId="LiveId" clId="{71F39E31-C0B6-4557-8E5D-4AAB538EC761}"/>
-    <pc:docChg chg="custSel modSld">
-      <pc:chgData name="Warren Feltmate" userId="06ccb0c333b4239d" providerId="LiveId" clId="{71F39E31-C0B6-4557-8E5D-4AAB538EC761}" dt="2025-03-03T03:12:09.230" v="16" actId="478"/>
-      <pc:docMkLst>
-        <pc:docMk/>
-      </pc:docMkLst>
-      <pc:sldChg chg="delSp modSp mod">
-        <pc:chgData name="Warren Feltmate" userId="06ccb0c333b4239d" providerId="LiveId" clId="{71F39E31-C0B6-4557-8E5D-4AAB538EC761}" dt="2025-03-03T03:12:09.230" v="16" actId="478"/>
-        <pc:sldMkLst>
-          <pc:docMk/>
-          <pc:sldMk cId="2986033172" sldId="258"/>
-        </pc:sldMkLst>
-      </pc:sldChg>
-    </pc:docChg>
-  </pc:docChgLst>
-  <pc:docChgLst>
-    <pc:chgData name="Warren Feltmate" userId="06ccb0c333b4239d" providerId="LiveId" clId="{46996535-2432-4770-B81A-3F0B8F4CD0E7}"/>
-    <pc:docChg chg="modSld">
-      <pc:chgData name="Warren Feltmate" userId="06ccb0c333b4239d" providerId="LiveId" clId="{46996535-2432-4770-B81A-3F0B8F4CD0E7}" dt="2025-03-26T20:55:11.080" v="5" actId="20577"/>
-      <pc:docMkLst>
-        <pc:docMk/>
-      </pc:docMkLst>
-      <pc:sldChg chg="modSp mod">
-        <pc:chgData name="Warren Feltmate" userId="06ccb0c333b4239d" providerId="LiveId" clId="{46996535-2432-4770-B81A-3F0B8F4CD0E7}" dt="2025-03-26T20:55:11.080" v="5" actId="20577"/>
-        <pc:sldMkLst>
-          <pc:docMk/>
-          <pc:sldMk cId="2986033172" sldId="258"/>
-        </pc:sldMkLst>
-        <pc:spChg chg="mod">
-          <ac:chgData name="Warren Feltmate" userId="06ccb0c333b4239d" providerId="LiveId" clId="{46996535-2432-4770-B81A-3F0B8F4CD0E7}" dt="2025-03-26T20:55:11.080" v="5" actId="20577"/>
-          <ac:spMkLst>
-            <pc:docMk/>
-            <pc:sldMk cId="2986033172" sldId="258"/>
-            <ac:spMk id="8" creationId="{EEE46E5F-FB90-FABC-4D3B-8E8E26233BC6}"/>
-          </ac:spMkLst>
-        </pc:spChg>
-      </pc:sldChg>
-    </pc:docChg>
-  </pc:docChgLst>
-  <pc:docChgLst>
-    <pc:chgData name="Warren Feltmate" userId="06ccb0c333b4239d" providerId="LiveId" clId="{AEF54D96-F37C-47E3-B213-270B77D44082}"/>
-    <pc:docChg chg="undo redo custSel delSld modSld modMainMaster delSection modSection">
-      <pc:chgData name="Warren Feltmate" userId="06ccb0c333b4239d" providerId="LiveId" clId="{AEF54D96-F37C-47E3-B213-270B77D44082}" dt="2025-03-01T17:57:22.559" v="1775" actId="179"/>
-      <pc:docMkLst>
-        <pc:docMk/>
-      </pc:docMkLst>
-      <pc:sldChg chg="delSp modSp del mod">
-        <pc:chgData name="Warren Feltmate" userId="06ccb0c333b4239d" providerId="LiveId" clId="{AEF54D96-F37C-47E3-B213-270B77D44082}" dt="2025-03-01T14:19:34.155" v="247" actId="47"/>
-        <pc:sldMkLst>
-          <pc:docMk/>
-          <pc:sldMk cId="2163217942" sldId="257"/>
-        </pc:sldMkLst>
-      </pc:sldChg>
-      <pc:sldChg chg="addSp delSp modSp mod modClrScheme chgLayout">
-        <pc:chgData name="Warren Feltmate" userId="06ccb0c333b4239d" providerId="LiveId" clId="{AEF54D96-F37C-47E3-B213-270B77D44082}" dt="2025-03-01T17:57:22.559" v="1775" actId="179"/>
-        <pc:sldMkLst>
-          <pc:docMk/>
-          <pc:sldMk cId="2986033172" sldId="258"/>
-        </pc:sldMkLst>
-      </pc:sldChg>
-      <pc:sldMasterChg chg="addSp delSp modSp mod modSldLayout sldLayoutOrd">
-        <pc:chgData name="Warren Feltmate" userId="06ccb0c333b4239d" providerId="LiveId" clId="{AEF54D96-F37C-47E3-B213-270B77D44082}" dt="2025-03-01T16:27:46.540" v="1541" actId="478"/>
-        <pc:sldMasterMkLst>
-          <pc:docMk/>
-          <pc:sldMasterMk cId="397249577" sldId="2147483660"/>
-        </pc:sldMasterMkLst>
-        <pc:sldLayoutChg chg="addSp delSp modSp mod">
-          <pc:chgData name="Warren Feltmate" userId="06ccb0c333b4239d" providerId="LiveId" clId="{AEF54D96-F37C-47E3-B213-270B77D44082}" dt="2025-03-01T13:57:45.199" v="97"/>
-          <pc:sldLayoutMkLst>
-            <pc:docMk/>
-            <pc:sldMasterMk cId="397249577" sldId="2147483660"/>
-            <pc:sldLayoutMk cId="3603283036" sldId="2147483661"/>
-          </pc:sldLayoutMkLst>
-        </pc:sldLayoutChg>
-        <pc:sldLayoutChg chg="addSp delSp modSp mod">
-          <pc:chgData name="Warren Feltmate" userId="06ccb0c333b4239d" providerId="LiveId" clId="{AEF54D96-F37C-47E3-B213-270B77D44082}" dt="2025-03-01T16:02:43.671" v="1408" actId="478"/>
-          <pc:sldLayoutMkLst>
-            <pc:docMk/>
-            <pc:sldMasterMk cId="397249577" sldId="2147483660"/>
-            <pc:sldLayoutMk cId="4144397055" sldId="2147483667"/>
-          </pc:sldLayoutMkLst>
-        </pc:sldLayoutChg>
-        <pc:sldLayoutChg chg="delSp mod ord">
-          <pc:chgData name="Warren Feltmate" userId="06ccb0c333b4239d" providerId="LiveId" clId="{AEF54D96-F37C-47E3-B213-270B77D44082}" dt="2025-03-01T09:34:56.435" v="46" actId="20578"/>
-          <pc:sldLayoutMkLst>
-            <pc:docMk/>
-            <pc:sldMasterMk cId="397249577" sldId="2147483660"/>
-            <pc:sldLayoutMk cId="2008870815" sldId="2147483668"/>
-          </pc:sldLayoutMkLst>
-        </pc:sldLayoutChg>
-      </pc:sldMasterChg>
-    </pc:docChg>
-  </pc:docChgLst>
-  <pc:docChgLst>
-    <pc:chgData name="Warren Feltmate" userId="06ccb0c333b4239d" providerId="LiveId" clId="{B8FED0F3-76DF-4D5B-91DB-080BD039BC07}"/>
-    <pc:docChg chg="undo redo custSel addSld delSld modSld modMainMaster modSection">
-      <pc:chgData name="Warren Feltmate" userId="06ccb0c333b4239d" providerId="LiveId" clId="{B8FED0F3-76DF-4D5B-91DB-080BD039BC07}" dt="2025-03-02T01:02:06.489" v="284" actId="5793"/>
-      <pc:docMkLst>
-        <pc:docMk/>
-      </pc:docMkLst>
-      <pc:sldChg chg="del">
-        <pc:chgData name="Warren Feltmate" userId="06ccb0c333b4239d" providerId="LiveId" clId="{B8FED0F3-76DF-4D5B-91DB-080BD039BC07}" dt="2025-03-01T09:02:57.904" v="0" actId="47"/>
-        <pc:sldMkLst>
-          <pc:docMk/>
-          <pc:sldMk cId="3247730059" sldId="256"/>
-        </pc:sldMkLst>
-      </pc:sldChg>
-      <pc:sldChg chg="modSp mod">
-        <pc:chgData name="Warren Feltmate" userId="06ccb0c333b4239d" providerId="LiveId" clId="{B8FED0F3-76DF-4D5B-91DB-080BD039BC07}" dt="2025-03-01T09:09:23.795" v="24" actId="179"/>
-        <pc:sldMkLst>
-          <pc:docMk/>
-          <pc:sldMk cId="2163217942" sldId="257"/>
-        </pc:sldMkLst>
-      </pc:sldChg>
-      <pc:sldChg chg="addSp delSp modSp new mod">
-        <pc:chgData name="Warren Feltmate" userId="06ccb0c333b4239d" providerId="LiveId" clId="{B8FED0F3-76DF-4D5B-91DB-080BD039BC07}" dt="2025-03-02T01:02:06.489" v="284" actId="5793"/>
-        <pc:sldMkLst>
-          <pc:docMk/>
-          <pc:sldMk cId="2986033172" sldId="258"/>
-        </pc:sldMkLst>
-      </pc:sldChg>
-      <pc:sldMasterChg chg="modSp mod modSldLayout sldLayoutOrd">
-        <pc:chgData name="Warren Feltmate" userId="06ccb0c333b4239d" providerId="LiveId" clId="{B8FED0F3-76DF-4D5B-91DB-080BD039BC07}" dt="2025-03-01T09:19:42.783" v="34" actId="478"/>
-        <pc:sldMasterMkLst>
-          <pc:docMk/>
-          <pc:sldMasterMk cId="397249577" sldId="2147483660"/>
-        </pc:sldMasterMkLst>
-        <pc:sldLayoutChg chg="addSp delSp modSp mod ord">
-          <pc:chgData name="Warren Feltmate" userId="06ccb0c333b4239d" providerId="LiveId" clId="{B8FED0F3-76DF-4D5B-91DB-080BD039BC07}" dt="2025-03-01T09:19:42.783" v="34" actId="478"/>
-          <pc:sldLayoutMkLst>
-            <pc:docMk/>
-            <pc:sldMasterMk cId="397249577" sldId="2147483660"/>
-            <pc:sldLayoutMk cId="3603283036" sldId="2147483661"/>
-          </pc:sldLayoutMkLst>
-        </pc:sldLayoutChg>
-        <pc:sldLayoutChg chg="modSp">
-          <pc:chgData name="Warren Feltmate" userId="06ccb0c333b4239d" providerId="LiveId" clId="{B8FED0F3-76DF-4D5B-91DB-080BD039BC07}" dt="2025-03-01T09:04:25.056" v="18"/>
-          <pc:sldLayoutMkLst>
-            <pc:docMk/>
-            <pc:sldMasterMk cId="397249577" sldId="2147483660"/>
-            <pc:sldLayoutMk cId="1482147029" sldId="2147483662"/>
-          </pc:sldLayoutMkLst>
-        </pc:sldLayoutChg>
-        <pc:sldLayoutChg chg="modSp">
-          <pc:chgData name="Warren Feltmate" userId="06ccb0c333b4239d" providerId="LiveId" clId="{B8FED0F3-76DF-4D5B-91DB-080BD039BC07}" dt="2025-03-01T09:04:25.056" v="18"/>
-          <pc:sldLayoutMkLst>
-            <pc:docMk/>
-            <pc:sldMasterMk cId="397249577" sldId="2147483660"/>
-            <pc:sldLayoutMk cId="3275218048" sldId="2147483663"/>
-          </pc:sldLayoutMkLst>
-        </pc:sldLayoutChg>
-        <pc:sldLayoutChg chg="modSp">
-          <pc:chgData name="Warren Feltmate" userId="06ccb0c333b4239d" providerId="LiveId" clId="{B8FED0F3-76DF-4D5B-91DB-080BD039BC07}" dt="2025-03-01T09:04:25.056" v="18"/>
-          <pc:sldLayoutMkLst>
-            <pc:docMk/>
-            <pc:sldMasterMk cId="397249577" sldId="2147483660"/>
-            <pc:sldLayoutMk cId="518273249" sldId="2147483664"/>
-          </pc:sldLayoutMkLst>
-        </pc:sldLayoutChg>
-        <pc:sldLayoutChg chg="modSp">
-          <pc:chgData name="Warren Feltmate" userId="06ccb0c333b4239d" providerId="LiveId" clId="{B8FED0F3-76DF-4D5B-91DB-080BD039BC07}" dt="2025-03-01T09:04:25.056" v="18"/>
-          <pc:sldLayoutMkLst>
-            <pc:docMk/>
-            <pc:sldMasterMk cId="397249577" sldId="2147483660"/>
-            <pc:sldLayoutMk cId="2272608395" sldId="2147483665"/>
-          </pc:sldLayoutMkLst>
-        </pc:sldLayoutChg>
-        <pc:sldLayoutChg chg="modSp">
-          <pc:chgData name="Warren Feltmate" userId="06ccb0c333b4239d" providerId="LiveId" clId="{B8FED0F3-76DF-4D5B-91DB-080BD039BC07}" dt="2025-03-01T09:04:25.056" v="18"/>
-          <pc:sldLayoutMkLst>
-            <pc:docMk/>
-            <pc:sldMasterMk cId="397249577" sldId="2147483660"/>
-            <pc:sldLayoutMk cId="1363059127" sldId="2147483666"/>
-          </pc:sldLayoutMkLst>
-        </pc:sldLayoutChg>
-        <pc:sldLayoutChg chg="addSp delSp modSp mod ord">
-          <pc:chgData name="Warren Feltmate" userId="06ccb0c333b4239d" providerId="LiveId" clId="{B8FED0F3-76DF-4D5B-91DB-080BD039BC07}" dt="2025-03-01T09:19:05.157" v="29" actId="22"/>
-          <pc:sldLayoutMkLst>
-            <pc:docMk/>
-            <pc:sldMasterMk cId="397249577" sldId="2147483660"/>
-            <pc:sldLayoutMk cId="4144397055" sldId="2147483667"/>
-          </pc:sldLayoutMkLst>
-        </pc:sldLayoutChg>
-        <pc:sldLayoutChg chg="modSp">
-          <pc:chgData name="Warren Feltmate" userId="06ccb0c333b4239d" providerId="LiveId" clId="{B8FED0F3-76DF-4D5B-91DB-080BD039BC07}" dt="2025-03-01T09:04:25.056" v="18"/>
-          <pc:sldLayoutMkLst>
-            <pc:docMk/>
-            <pc:sldMasterMk cId="397249577" sldId="2147483660"/>
-            <pc:sldLayoutMk cId="2695737696" sldId="2147483668"/>
-          </pc:sldLayoutMkLst>
-        </pc:sldLayoutChg>
-      </pc:sldMasterChg>
-    </pc:docChg>
-  </pc:docChgLst>
-  <pc:docChgLst>
-    <pc:chgData name="Warren Feltmate" userId="06ccb0c333b4239d" providerId="LiveId" clId="{9C6A9A9F-D35F-664C-948C-54498E255F5C}"/>
-    <pc:docChg chg="modSld">
-      <pc:chgData name="Warren Feltmate" userId="06ccb0c333b4239d" providerId="LiveId" clId="{9C6A9A9F-D35F-664C-948C-54498E255F5C}" dt="2025-03-07T18:08:40.481" v="3" actId="20577"/>
-      <pc:docMkLst>
-        <pc:docMk/>
-      </pc:docMkLst>
-      <pc:sldChg chg="modSp mod">
-        <pc:chgData name="Warren Feltmate" userId="06ccb0c333b4239d" providerId="LiveId" clId="{9C6A9A9F-D35F-664C-948C-54498E255F5C}" dt="2025-03-07T18:08:40.481" v="3" actId="20577"/>
-        <pc:sldMkLst>
-          <pc:docMk/>
-          <pc:sldMk cId="2986033172" sldId="258"/>
-        </pc:sldMkLst>
-      </pc:sldChg>
-    </pc:docChg>
-  </pc:docChgLst>
-  <pc:docChgLst>
-    <pc:chgData name="Warren Feltmate" userId="06ccb0c333b4239d" providerId="LiveId" clId="{D0CF374C-DFBE-455C-A58A-63EDDBC9C852}"/>
-    <pc:docChg chg="modSld">
-      <pc:chgData name="Warren Feltmate" userId="06ccb0c333b4239d" providerId="LiveId" clId="{D0CF374C-DFBE-455C-A58A-63EDDBC9C852}" dt="2025-03-26T20:40:30.199" v="32" actId="2711"/>
-      <pc:docMkLst>
-        <pc:docMk/>
-      </pc:docMkLst>
-      <pc:sldChg chg="modSp mod">
-        <pc:chgData name="Warren Feltmate" userId="06ccb0c333b4239d" providerId="LiveId" clId="{D0CF374C-DFBE-455C-A58A-63EDDBC9C852}" dt="2025-03-26T20:40:30.199" v="32" actId="2711"/>
-        <pc:sldMkLst>
-          <pc:docMk/>
-          <pc:sldMk cId="2986033172" sldId="258"/>
-        </pc:sldMkLst>
-        <pc:spChg chg="mod">
-          <ac:chgData name="Warren Feltmate" userId="06ccb0c333b4239d" providerId="LiveId" clId="{D0CF374C-DFBE-455C-A58A-63EDDBC9C852}" dt="2025-03-26T20:40:11.872" v="31" actId="1036"/>
-          <ac:spMkLst>
-            <pc:docMk/>
-            <pc:sldMk cId="2986033172" sldId="258"/>
-            <ac:spMk id="5" creationId="{9456CAC5-6CD1-0CBF-C271-A5041AC6163F}"/>
-          </ac:spMkLst>
-        </pc:spChg>
-        <pc:spChg chg="mod">
-          <ac:chgData name="Warren Feltmate" userId="06ccb0c333b4239d" providerId="LiveId" clId="{D0CF374C-DFBE-455C-A58A-63EDDBC9C852}" dt="2025-03-26T20:40:11.872" v="31" actId="1036"/>
-          <ac:spMkLst>
-            <pc:docMk/>
-            <pc:sldMk cId="2986033172" sldId="258"/>
-            <ac:spMk id="6" creationId="{33934AC6-4CEA-9AEF-F212-4A4152C6E130}"/>
-          </ac:spMkLst>
-        </pc:spChg>
-        <pc:spChg chg="mod">
-          <ac:chgData name="Warren Feltmate" userId="06ccb0c333b4239d" providerId="LiveId" clId="{D0CF374C-DFBE-455C-A58A-63EDDBC9C852}" dt="2025-03-26T20:40:11.872" v="31" actId="1036"/>
-          <ac:spMkLst>
-            <pc:docMk/>
-            <pc:sldMk cId="2986033172" sldId="258"/>
-            <ac:spMk id="7" creationId="{07BC5B6D-04B8-E053-FB3A-687109589539}"/>
-          </ac:spMkLst>
-        </pc:spChg>
-        <pc:spChg chg="mod">
-          <ac:chgData name="Warren Feltmate" userId="06ccb0c333b4239d" providerId="LiveId" clId="{D0CF374C-DFBE-455C-A58A-63EDDBC9C852}" dt="2025-03-26T20:40:30.199" v="32" actId="2711"/>
-          <ac:spMkLst>
-            <pc:docMk/>
-            <pc:sldMk cId="2986033172" sldId="258"/>
-            <ac:spMk id="8" creationId="{EEE46E5F-FB90-FABC-4D3B-8E8E26233BC6}"/>
-          </ac:spMkLst>
-        </pc:spChg>
-        <pc:spChg chg="mod">
-          <ac:chgData name="Warren Feltmate" userId="06ccb0c333b4239d" providerId="LiveId" clId="{D0CF374C-DFBE-455C-A58A-63EDDBC9C852}" dt="2025-03-26T20:40:11.872" v="31" actId="1036"/>
-          <ac:spMkLst>
-            <pc:docMk/>
-            <pc:sldMk cId="2986033172" sldId="258"/>
-            <ac:spMk id="9" creationId="{6EBD9C66-9284-1D3E-CF00-9A8077CE630E}"/>
-          </ac:spMkLst>
-        </pc:spChg>
-      </pc:sldChg>
-    </pc:docChg>
-  </pc:docChgLst>
-  <pc:docChgLst>
-    <pc:chgData name="Warren Feltmate" userId="06ccb0c333b4239d" providerId="LiveId" clId="{30BCAE99-08E2-477F-9EE6-F9385C2082AC}"/>
-    <pc:docChg chg="modSld">
-      <pc:chgData name="Warren Feltmate" userId="06ccb0c333b4239d" providerId="LiveId" clId="{30BCAE99-08E2-477F-9EE6-F9385C2082AC}" dt="2025-06-24T19:33:43.931" v="5" actId="20577"/>
-      <pc:docMkLst>
-        <pc:docMk/>
-      </pc:docMkLst>
-      <pc:sldChg chg="modSp mod">
-        <pc:chgData name="Warren Feltmate" userId="06ccb0c333b4239d" providerId="LiveId" clId="{30BCAE99-08E2-477F-9EE6-F9385C2082AC}" dt="2025-06-24T19:33:43.931" v="5" actId="20577"/>
-        <pc:sldMkLst>
-          <pc:docMk/>
-          <pc:sldMk cId="2986033172" sldId="258"/>
-        </pc:sldMkLst>
-        <pc:spChg chg="mod">
-          <ac:chgData name="Warren Feltmate" userId="06ccb0c333b4239d" providerId="LiveId" clId="{30BCAE99-08E2-477F-9EE6-F9385C2082AC}" dt="2025-06-24T19:33:43.931" v="5" actId="20577"/>
-          <ac:spMkLst>
-            <pc:docMk/>
-            <pc:sldMk cId="2986033172" sldId="258"/>
-            <ac:spMk id="8" creationId="{EEE46E5F-FB90-FABC-4D3B-8E8E26233BC6}"/>
-          </ac:spMkLst>
-        </pc:spChg>
-        <pc:spChg chg="mod">
-          <ac:chgData name="Warren Feltmate" userId="06ccb0c333b4239d" providerId="LiveId" clId="{30BCAE99-08E2-477F-9EE6-F9385C2082AC}" dt="2025-06-24T19:33:35.408" v="0" actId="2711"/>
-          <ac:spMkLst>
-            <pc:docMk/>
-            <pc:sldMk cId="2986033172" sldId="258"/>
-            <ac:spMk id="13" creationId="{F00BC8B0-E661-32E3-D720-624E8267977F}"/>
-          </ac:spMkLst>
-        </pc:spChg>
-        <pc:spChg chg="mod">
-          <ac:chgData name="Warren Feltmate" userId="06ccb0c333b4239d" providerId="LiveId" clId="{30BCAE99-08E2-477F-9EE6-F9385C2082AC}" dt="2025-06-24T19:33:39.582" v="1" actId="2711"/>
-          <ac:spMkLst>
-            <pc:docMk/>
-            <pc:sldMk cId="2986033172" sldId="258"/>
-            <ac:spMk id="14" creationId="{5359B18E-C7E0-FDAE-6A24-F1F6551FDB0F}"/>
-          </ac:spMkLst>
-        </pc:spChg>
-      </pc:sldChg>
-    </pc:docChg>
-  </pc:docChgLst>
-  <pc:docChgLst>
-    <pc:chgData name="Warren Feltmate" userId="06ccb0c333b4239d" providerId="LiveId" clId="{B7DFDAEE-DCB3-43D7-B32B-253E4B2B6A2F}"/>
-    <pc:docChg chg="undo redo custSel modSld">
-      <pc:chgData name="Warren Feltmate" userId="06ccb0c333b4239d" providerId="LiveId" clId="{B7DFDAEE-DCB3-43D7-B32B-253E4B2B6A2F}" dt="2025-05-10T20:06:00.592" v="208"/>
-      <pc:docMkLst>
-        <pc:docMk/>
-      </pc:docMkLst>
-      <pc:sldChg chg="modSp mod">
-        <pc:chgData name="Warren Feltmate" userId="06ccb0c333b4239d" providerId="LiveId" clId="{B7DFDAEE-DCB3-43D7-B32B-253E4B2B6A2F}" dt="2025-05-10T20:06:00.592" v="208"/>
-        <pc:sldMkLst>
-          <pc:docMk/>
-          <pc:sldMk cId="2986033172" sldId="258"/>
-        </pc:sldMkLst>
-        <pc:spChg chg="mod">
-          <ac:chgData name="Warren Feltmate" userId="06ccb0c333b4239d" providerId="LiveId" clId="{B7DFDAEE-DCB3-43D7-B32B-253E4B2B6A2F}" dt="2025-05-10T20:04:25.243" v="198" actId="403"/>
-          <ac:spMkLst>
-            <pc:docMk/>
-            <pc:sldMk cId="2986033172" sldId="258"/>
-            <ac:spMk id="5" creationId="{9456CAC5-6CD1-0CBF-C271-A5041AC6163F}"/>
-          </ac:spMkLst>
-        </pc:spChg>
-        <pc:spChg chg="mod">
-          <ac:chgData name="Warren Feltmate" userId="06ccb0c333b4239d" providerId="LiveId" clId="{B7DFDAEE-DCB3-43D7-B32B-253E4B2B6A2F}" dt="2025-05-10T20:06:00.592" v="208"/>
-          <ac:spMkLst>
-            <pc:docMk/>
-            <pc:sldMk cId="2986033172" sldId="258"/>
-            <ac:spMk id="6" creationId="{33934AC6-4CEA-9AEF-F212-4A4152C6E130}"/>
-          </ac:spMkLst>
-        </pc:spChg>
-        <pc:spChg chg="mod">
-          <ac:chgData name="Warren Feltmate" userId="06ccb0c333b4239d" providerId="LiveId" clId="{B7DFDAEE-DCB3-43D7-B32B-253E4B2B6A2F}" dt="2025-05-10T19:04:21.754" v="176"/>
-          <ac:spMkLst>
-            <pc:docMk/>
-            <pc:sldMk cId="2986033172" sldId="258"/>
-            <ac:spMk id="7" creationId="{07BC5B6D-04B8-E053-FB3A-687109589539}"/>
-          </ac:spMkLst>
-        </pc:spChg>
-        <pc:spChg chg="mod">
-          <ac:chgData name="Warren Feltmate" userId="06ccb0c333b4239d" providerId="LiveId" clId="{B7DFDAEE-DCB3-43D7-B32B-253E4B2B6A2F}" dt="2025-05-10T19:04:21.754" v="176"/>
-          <ac:spMkLst>
-            <pc:docMk/>
-            <pc:sldMk cId="2986033172" sldId="258"/>
-            <ac:spMk id="9" creationId="{6EBD9C66-9284-1D3E-CF00-9A8077CE630E}"/>
-          </ac:spMkLst>
-        </pc:spChg>
-        <pc:spChg chg="mod">
-          <ac:chgData name="Warren Feltmate" userId="06ccb0c333b4239d" providerId="LiveId" clId="{B7DFDAEE-DCB3-43D7-B32B-253E4B2B6A2F}" dt="2025-05-10T20:04:44.956" v="199" actId="404"/>
-          <ac:spMkLst>
-            <pc:docMk/>
-            <pc:sldMk cId="2986033172" sldId="258"/>
-            <ac:spMk id="13" creationId="{F00BC8B0-E661-32E3-D720-624E8267977F}"/>
-          </ac:spMkLst>
-        </pc:spChg>
-        <pc:spChg chg="mod">
-          <ac:chgData name="Warren Feltmate" userId="06ccb0c333b4239d" providerId="LiveId" clId="{B7DFDAEE-DCB3-43D7-B32B-253E4B2B6A2F}" dt="2025-05-10T20:04:44.956" v="199" actId="404"/>
-          <ac:spMkLst>
-            <pc:docMk/>
-            <pc:sldMk cId="2986033172" sldId="258"/>
-            <ac:spMk id="14" creationId="{5359B18E-C7E0-FDAE-6A24-F1F6551FDB0F}"/>
-          </ac:spMkLst>
-        </pc:spChg>
-        <pc:grpChg chg="mod">
-          <ac:chgData name="Warren Feltmate" userId="06ccb0c333b4239d" providerId="LiveId" clId="{B7DFDAEE-DCB3-43D7-B32B-253E4B2B6A2F}" dt="2025-05-10T19:04:21.754" v="176"/>
-          <ac:grpSpMkLst>
-            <pc:docMk/>
-            <pc:sldMk cId="2986033172" sldId="258"/>
-            <ac:grpSpMk id="15" creationId="{000FCD74-4D4D-F8D6-E04D-7A5B8B36D5DE}"/>
-          </ac:grpSpMkLst>
-        </pc:grpChg>
-      </pc:sldChg>
-    </pc:docChg>
-  </pc:docChgLst>
-</pc:chgInfo>
 </file>
 
 <file path=ppt/slideLayouts/slideLayout1.xml><?xml version="1.0" encoding="utf-8"?>
@@ -6026,354 +5619,80 @@
           <a:lstStyle/>
           <a:p>
             <a:r>
-              <a:rPr lang="en-US" sz="2400">
+              <a:rPr lang="en-US" dirty="0">
                 <a:solidFill>
                   <a:schemeClr val="tx1"/>
                 </a:solidFill>
-                <a:latin typeface="Just Another Hand" panose="02000506000000020003" pitchFamily="2" charset="0"/>
+                <a:latin typeface="Segoe UI Semibold" panose="020B0702040204020203" pitchFamily="34" charset="0"/>
                 <a:ea typeface="A little sunshine" panose="02000603000000000000" pitchFamily="2" charset="0"/>
+                <a:cs typeface="Segoe UI Semibold" panose="020B0702040204020203" pitchFamily="34" charset="0"/>
               </a:rPr>
-              <a:t>Temp</a:t>
+              <a:t>Comment text</a:t>
             </a:r>
-            <a:endParaRPr lang="en-US" sz="2400" dirty="0">
-              <a:solidFill>
-                <a:schemeClr val="tx1"/>
-              </a:solidFill>
-              <a:latin typeface="Just Another Hand" panose="02000506000000020003" pitchFamily="2" charset="0"/>
-              <a:ea typeface="A little sunshine" panose="02000603000000000000" pitchFamily="2" charset="0"/>
-            </a:endParaRPr>
           </a:p>
         </p:txBody>
       </p:sp>
-      <p:grpSp>
-        <p:nvGrpSpPr>
-          <p:cNvPr id="78" name="Result_Scores">
+      <p:sp>
+        <p:nvSpPr>
+          <p:cNvPr id="44" name="Overall_Grade">
             <a:extLst>
               <a:ext uri="{FF2B5EF4-FFF2-40B4-BE49-F238E27FC236}">
-                <a16:creationId xmlns:a16="http://schemas.microsoft.com/office/drawing/2014/main" id="{B089F30F-8BD3-0ED6-2A4A-13BF7F0A7BAE}"/>
+                <a16:creationId xmlns:a16="http://schemas.microsoft.com/office/drawing/2014/main" id="{7AAD70C8-B23B-5F30-CD5F-D96FE12BBA29}"/>
               </a:ext>
             </a:extLst>
           </p:cNvPr>
-          <p:cNvGrpSpPr>
-            <a:grpSpLocks noGrp="1" noUngrp="1" noRot="1" noMove="1" noResize="1"/>
-          </p:cNvGrpSpPr>
+          <p:cNvSpPr>
+            <a:spLocks noGrp="1" noRot="1" noMove="1" noResize="1" noEditPoints="1" noAdjustHandles="1" noChangeArrowheads="1" noChangeShapeType="1"/>
+          </p:cNvSpPr>
           <p:nvPr/>
-        </p:nvGrpSpPr>
-        <p:grpSpPr>
+        </p:nvSpPr>
+        <p:spPr>
           <a:xfrm>
             <a:off x="1536501" y="9334500"/>
             <a:ext cx="548640" cy="273844"/>
-            <a:chOff x="1536501" y="9334500"/>
-            <a:chExt cx="548640" cy="273844"/>
           </a:xfrm>
-        </p:grpSpPr>
-        <p:sp>
-          <p:nvSpPr>
-            <p:cNvPr id="41" name="Result_C">
-              <a:extLst>
-                <a:ext uri="{FF2B5EF4-FFF2-40B4-BE49-F238E27FC236}">
-                  <a16:creationId xmlns:a16="http://schemas.microsoft.com/office/drawing/2014/main" id="{DD18F7AF-DC9A-DA6E-EFC8-5403C21A2F07}"/>
-                </a:ext>
-              </a:extLst>
-            </p:cNvPr>
-            <p:cNvSpPr>
-              <a:spLocks noGrp="1" noRot="1" noMove="1" noResize="1" noEditPoints="1" noAdjustHandles="1" noChangeArrowheads="1" noChangeShapeType="1"/>
-            </p:cNvSpPr>
-            <p:nvPr/>
-          </p:nvSpPr>
-          <p:spPr>
-            <a:xfrm>
-              <a:off x="1536501" y="9334500"/>
-              <a:ext cx="548640" cy="273844"/>
-            </a:xfrm>
-            <a:prstGeom prst="rect">
-              <a:avLst/>
-            </a:prstGeom>
+          <a:prstGeom prst="rect">
+            <a:avLst/>
+          </a:prstGeom>
+          <a:noFill/>
+          <a:ln>
             <a:noFill/>
-            <a:ln>
-              <a:noFill/>
-            </a:ln>
-          </p:spPr>
-          <p:style>
-            <a:lnRef idx="2">
-              <a:schemeClr val="accent1">
-                <a:shade val="15000"/>
-              </a:schemeClr>
-            </a:lnRef>
-            <a:fillRef idx="1">
-              <a:schemeClr val="accent1"/>
-            </a:fillRef>
-            <a:effectRef idx="0">
-              <a:schemeClr val="accent1"/>
-            </a:effectRef>
-            <a:fontRef idx="minor">
-              <a:schemeClr val="lt1"/>
-            </a:fontRef>
-          </p:style>
-          <p:txBody>
-            <a:bodyPr rtlCol="0" anchor="ctr"/>
-            <a:lstStyle/>
-            <a:p>
-              <a:pPr algn="ctr"/>
-              <a:r>
-                <a:rPr lang="en-US" b="1" dirty="0">
-                  <a:solidFill>
-                    <a:schemeClr val="tx1"/>
-                  </a:solidFill>
-                  <a:latin typeface="Times New Roman" panose="02020603050405020304" pitchFamily="18" charset="0"/>
-                  <a:cs typeface="Times New Roman" panose="02020603050405020304" pitchFamily="18" charset="0"/>
-                </a:rPr>
-                <a:t>C</a:t>
-              </a:r>
-            </a:p>
-          </p:txBody>
-        </p:sp>
-        <p:sp>
-          <p:nvSpPr>
-            <p:cNvPr id="42" name="Result_B">
-              <a:extLst>
-                <a:ext uri="{FF2B5EF4-FFF2-40B4-BE49-F238E27FC236}">
-                  <a16:creationId xmlns:a16="http://schemas.microsoft.com/office/drawing/2014/main" id="{466122BA-0038-6085-94B0-99919CDD695D}"/>
-                </a:ext>
-              </a:extLst>
-            </p:cNvPr>
-            <p:cNvSpPr>
-              <a:spLocks noGrp="1" noRot="1" noMove="1" noResize="1" noEditPoints="1" noAdjustHandles="1" noChangeArrowheads="1" noChangeShapeType="1"/>
-            </p:cNvSpPr>
-            <p:nvPr/>
-          </p:nvSpPr>
-          <p:spPr>
-            <a:xfrm>
-              <a:off x="1536501" y="9334500"/>
-              <a:ext cx="548640" cy="273844"/>
-            </a:xfrm>
-            <a:prstGeom prst="rect">
-              <a:avLst/>
-            </a:prstGeom>
-            <a:noFill/>
-            <a:ln>
-              <a:noFill/>
-            </a:ln>
-          </p:spPr>
-          <p:style>
-            <a:lnRef idx="2">
-              <a:schemeClr val="accent1">
-                <a:shade val="15000"/>
-              </a:schemeClr>
-            </a:lnRef>
-            <a:fillRef idx="1">
-              <a:schemeClr val="accent1"/>
-            </a:fillRef>
-            <a:effectRef idx="0">
-              <a:schemeClr val="accent1"/>
-            </a:effectRef>
-            <a:fontRef idx="minor">
-              <a:schemeClr val="lt1"/>
-            </a:fontRef>
-          </p:style>
-          <p:txBody>
-            <a:bodyPr rtlCol="0" anchor="ctr"/>
-            <a:lstStyle/>
-            <a:p>
-              <a:pPr algn="ctr"/>
-              <a:r>
-                <a:rPr lang="en-US" b="1" dirty="0">
-                  <a:solidFill>
-                    <a:schemeClr val="tx1"/>
-                  </a:solidFill>
-                  <a:latin typeface="Times New Roman" panose="02020603050405020304" pitchFamily="18" charset="0"/>
-                  <a:cs typeface="Times New Roman" panose="02020603050405020304" pitchFamily="18" charset="0"/>
-                </a:rPr>
-                <a:t>B</a:t>
-              </a:r>
-            </a:p>
-          </p:txBody>
-        </p:sp>
-        <p:sp>
-          <p:nvSpPr>
-            <p:cNvPr id="45" name="Result_B+">
-              <a:extLst>
-                <a:ext uri="{FF2B5EF4-FFF2-40B4-BE49-F238E27FC236}">
-                  <a16:creationId xmlns:a16="http://schemas.microsoft.com/office/drawing/2014/main" id="{DDE73D3C-B64D-2782-6780-6B976C8A9A15}"/>
-                </a:ext>
-              </a:extLst>
-            </p:cNvPr>
-            <p:cNvSpPr>
-              <a:spLocks noGrp="1" noRot="1" noMove="1" noResize="1" noEditPoints="1" noAdjustHandles="1" noChangeArrowheads="1" noChangeShapeType="1"/>
-            </p:cNvSpPr>
-            <p:nvPr/>
-          </p:nvSpPr>
-          <p:spPr>
-            <a:xfrm>
-              <a:off x="1536501" y="9334500"/>
-              <a:ext cx="548640" cy="273844"/>
-            </a:xfrm>
-            <a:prstGeom prst="rect">
-              <a:avLst/>
-            </a:prstGeom>
-            <a:noFill/>
-            <a:ln>
-              <a:noFill/>
-            </a:ln>
-          </p:spPr>
-          <p:style>
-            <a:lnRef idx="2">
-              <a:schemeClr val="accent1">
-                <a:shade val="15000"/>
-              </a:schemeClr>
-            </a:lnRef>
-            <a:fillRef idx="1">
-              <a:schemeClr val="accent1"/>
-            </a:fillRef>
-            <a:effectRef idx="0">
-              <a:schemeClr val="accent1"/>
-            </a:effectRef>
-            <a:fontRef idx="minor">
-              <a:schemeClr val="lt1"/>
-            </a:fontRef>
-          </p:style>
-          <p:txBody>
-            <a:bodyPr rtlCol="0" anchor="ctr"/>
-            <a:lstStyle/>
-            <a:p>
-              <a:pPr algn="ctr"/>
-              <a:r>
-                <a:rPr lang="en-US" b="1" dirty="0">
-                  <a:solidFill>
-                    <a:schemeClr val="tx1"/>
-                  </a:solidFill>
-                  <a:latin typeface="Times New Roman" panose="02020603050405020304" pitchFamily="18" charset="0"/>
-                  <a:cs typeface="Times New Roman" panose="02020603050405020304" pitchFamily="18" charset="0"/>
-                </a:rPr>
-                <a:t>B+</a:t>
-              </a:r>
-            </a:p>
-          </p:txBody>
-        </p:sp>
-        <p:sp>
-          <p:nvSpPr>
-            <p:cNvPr id="43" name="Result_A">
-              <a:extLst>
-                <a:ext uri="{FF2B5EF4-FFF2-40B4-BE49-F238E27FC236}">
-                  <a16:creationId xmlns:a16="http://schemas.microsoft.com/office/drawing/2014/main" id="{CD08E964-AFE0-199A-911B-A92D65CDA2AA}"/>
-                </a:ext>
-              </a:extLst>
-            </p:cNvPr>
-            <p:cNvSpPr>
-              <a:spLocks noGrp="1" noRot="1" noMove="1" noResize="1" noEditPoints="1" noAdjustHandles="1" noChangeArrowheads="1" noChangeShapeType="1"/>
-            </p:cNvSpPr>
-            <p:nvPr/>
-          </p:nvSpPr>
-          <p:spPr>
-            <a:xfrm>
-              <a:off x="1536501" y="9334500"/>
-              <a:ext cx="548640" cy="273844"/>
-            </a:xfrm>
-            <a:prstGeom prst="rect">
-              <a:avLst/>
-            </a:prstGeom>
-            <a:noFill/>
-            <a:ln>
-              <a:noFill/>
-            </a:ln>
-          </p:spPr>
-          <p:style>
-            <a:lnRef idx="2">
-              <a:schemeClr val="accent1">
-                <a:shade val="15000"/>
-              </a:schemeClr>
-            </a:lnRef>
-            <a:fillRef idx="1">
-              <a:schemeClr val="accent1"/>
-            </a:fillRef>
-            <a:effectRef idx="0">
-              <a:schemeClr val="accent1"/>
-            </a:effectRef>
-            <a:fontRef idx="minor">
-              <a:schemeClr val="lt1"/>
-            </a:fontRef>
-          </p:style>
-          <p:txBody>
-            <a:bodyPr rtlCol="0" anchor="ctr"/>
-            <a:lstStyle/>
-            <a:p>
-              <a:pPr algn="ctr"/>
-              <a:r>
-                <a:rPr lang="en-US" b="1" dirty="0">
-                  <a:solidFill>
-                    <a:schemeClr val="tx1"/>
-                  </a:solidFill>
-                  <a:latin typeface="Times New Roman" panose="02020603050405020304" pitchFamily="18" charset="0"/>
-                  <a:cs typeface="Times New Roman" panose="02020603050405020304" pitchFamily="18" charset="0"/>
-                </a:rPr>
-                <a:t>A</a:t>
-              </a:r>
-              <a:endParaRPr lang="en-US" b="1" dirty="0"/>
-            </a:p>
-          </p:txBody>
-        </p:sp>
-        <p:sp>
-          <p:nvSpPr>
-            <p:cNvPr id="44" name="Result_A+">
-              <a:extLst>
-                <a:ext uri="{FF2B5EF4-FFF2-40B4-BE49-F238E27FC236}">
-                  <a16:creationId xmlns:a16="http://schemas.microsoft.com/office/drawing/2014/main" id="{7AAD70C8-B23B-5F30-CD5F-D96FE12BBA29}"/>
-                </a:ext>
-              </a:extLst>
-            </p:cNvPr>
-            <p:cNvSpPr>
-              <a:spLocks noGrp="1" noRot="1" noMove="1" noResize="1" noEditPoints="1" noAdjustHandles="1" noChangeArrowheads="1" noChangeShapeType="1"/>
-            </p:cNvSpPr>
-            <p:nvPr/>
-          </p:nvSpPr>
-          <p:spPr>
-            <a:xfrm>
-              <a:off x="1536501" y="9334500"/>
-              <a:ext cx="548640" cy="273844"/>
-            </a:xfrm>
-            <a:prstGeom prst="rect">
-              <a:avLst/>
-            </a:prstGeom>
-            <a:noFill/>
-            <a:ln>
-              <a:noFill/>
-            </a:ln>
-          </p:spPr>
-          <p:style>
-            <a:lnRef idx="2">
-              <a:schemeClr val="accent1">
-                <a:shade val="15000"/>
-              </a:schemeClr>
-            </a:lnRef>
-            <a:fillRef idx="1">
-              <a:schemeClr val="accent1"/>
-            </a:fillRef>
-            <a:effectRef idx="0">
-              <a:schemeClr val="accent1"/>
-            </a:effectRef>
-            <a:fontRef idx="minor">
-              <a:schemeClr val="lt1"/>
-            </a:fontRef>
-          </p:style>
-          <p:txBody>
-            <a:bodyPr rtlCol="0" anchor="ctr"/>
-            <a:lstStyle/>
-            <a:p>
-              <a:pPr algn="ctr"/>
-              <a:r>
-                <a:rPr lang="en-US" b="1" dirty="0">
-                  <a:solidFill>
-                    <a:schemeClr val="tx1"/>
-                  </a:solidFill>
-                  <a:latin typeface="Times New Roman" panose="02020603050405020304" pitchFamily="18" charset="0"/>
-                  <a:cs typeface="Times New Roman" panose="02020603050405020304" pitchFamily="18" charset="0"/>
-                </a:rPr>
-                <a:t>A+</a:t>
-              </a:r>
-            </a:p>
-          </p:txBody>
-        </p:sp>
-      </p:grpSp>
+          </a:ln>
+        </p:spPr>
+        <p:style>
+          <a:lnRef idx="2">
+            <a:schemeClr val="accent1">
+              <a:shade val="15000"/>
+            </a:schemeClr>
+          </a:lnRef>
+          <a:fillRef idx="1">
+            <a:schemeClr val="accent1"/>
+          </a:fillRef>
+          <a:effectRef idx="0">
+            <a:schemeClr val="accent1"/>
+          </a:effectRef>
+          <a:fontRef idx="minor">
+            <a:schemeClr val="lt1"/>
+          </a:fontRef>
+        </p:style>
+        <p:txBody>
+          <a:bodyPr rtlCol="0" anchor="ctr"/>
+          <a:lstStyle/>
+          <a:p>
+            <a:pPr algn="ctr"/>
+            <a:r>
+              <a:rPr lang="en-US" b="1" dirty="0">
+                <a:solidFill>
+                  <a:schemeClr val="tx1"/>
+                </a:solidFill>
+                <a:latin typeface="Times New Roman" panose="02020603050405020304" pitchFamily="18" charset="0"/>
+                <a:cs typeface="Times New Roman" panose="02020603050405020304" pitchFamily="18" charset="0"/>
+              </a:rPr>
+              <a:t>A+</a:t>
+            </a:r>
+          </a:p>
+        </p:txBody>
+      </p:sp>
       <p:grpSp>
         <p:nvGrpSpPr>
           <p:cNvPr id="77" name="Effort_Scores">
@@ -8348,337 +7667,324 @@
           </p:txBody>
         </p:sp>
       </p:grpSp>
-      <p:grpSp>
-        <p:nvGrpSpPr>
-          <p:cNvPr id="15" name="Report_Header">
+      <p:sp>
+        <p:nvSpPr>
+          <p:cNvPr id="7" name="Eval_Date">
             <a:extLst>
               <a:ext uri="{FF2B5EF4-FFF2-40B4-BE49-F238E27FC236}">
-                <a16:creationId xmlns:a16="http://schemas.microsoft.com/office/drawing/2014/main" id="{000FCD74-4D4D-F8D6-E04D-7A5B8B36D5DE}"/>
+                <a16:creationId xmlns:a16="http://schemas.microsoft.com/office/drawing/2014/main" id="{07BC5B6D-04B8-E053-FB3A-687109589539}"/>
               </a:ext>
             </a:extLst>
           </p:cNvPr>
-          <p:cNvGrpSpPr/>
+          <p:cNvSpPr txBox="1"/>
           <p:nvPr/>
-        </p:nvGrpSpPr>
-        <p:grpSpPr>
+        </p:nvSpPr>
+        <p:spPr>
           <a:xfrm>
-            <a:off x="1485899" y="812800"/>
-            <a:ext cx="4922522" cy="822290"/>
-            <a:chOff x="1485899" y="812800"/>
-            <a:chExt cx="4922522" cy="822290"/>
+            <a:off x="5260339" y="1271016"/>
+            <a:ext cx="1259844" cy="329184"/>
           </a:xfrm>
-        </p:grpSpPr>
-        <p:sp>
-          <p:nvSpPr>
-            <p:cNvPr id="7" name="Eval_Date">
-              <a:extLst>
-                <a:ext uri="{FF2B5EF4-FFF2-40B4-BE49-F238E27FC236}">
-                  <a16:creationId xmlns:a16="http://schemas.microsoft.com/office/drawing/2014/main" id="{07BC5B6D-04B8-E053-FB3A-687109589539}"/>
-                </a:ext>
-              </a:extLst>
-            </p:cNvPr>
-            <p:cNvSpPr txBox="1"/>
-            <p:nvPr/>
-          </p:nvSpPr>
-          <p:spPr>
-            <a:xfrm>
-              <a:off x="5372101" y="1280160"/>
-              <a:ext cx="1036320" cy="354930"/>
-            </a:xfrm>
-            <a:prstGeom prst="rect">
-              <a:avLst/>
-            </a:prstGeom>
-            <a:noFill/>
-          </p:spPr>
-          <p:txBody>
-            <a:bodyPr wrap="square" lIns="45720" rIns="45720" anchor="b" anchorCtr="0">
-              <a:noAutofit/>
-            </a:bodyPr>
-            <a:lstStyle/>
-            <a:p>
-              <a:pPr algn="ctr"/>
-              <a:r>
-                <a:rPr kumimoji="0" lang="en-US" sz="2000" i="0" u="none" strike="noStrike" kern="1200" cap="none" spc="0" normalizeH="0" baseline="0" noProof="0" dirty="0">
-                  <a:ln>
-                    <a:noFill/>
-                  </a:ln>
-                  <a:solidFill>
-                    <a:prstClr val="black"/>
-                  </a:solidFill>
-                  <a:effectLst/>
-                  <a:uLnTx/>
-                  <a:uFillTx/>
-                  <a:latin typeface="Just Another Hand" panose="02000506000000020003" pitchFamily="2" charset="0"/>
-                  <a:ea typeface="A little sunshine" pitchFamily="2" charset="0"/>
-                </a:rPr>
-                <a:t>Mar. 2025</a:t>
-              </a:r>
-              <a:endParaRPr lang="en-US" sz="3200" dirty="0">
-                <a:latin typeface="Just Another Hand" panose="02000506000000020003" pitchFamily="2" charset="0"/>
-              </a:endParaRPr>
-            </a:p>
-          </p:txBody>
-        </p:sp>
-        <p:sp>
-          <p:nvSpPr>
-            <p:cNvPr id="14" name="Korean_Teacher">
-              <a:extLst>
-                <a:ext uri="{FF2B5EF4-FFF2-40B4-BE49-F238E27FC236}">
-                  <a16:creationId xmlns:a16="http://schemas.microsoft.com/office/drawing/2014/main" id="{5359B18E-C7E0-FDAE-6A24-F1F6551FDB0F}"/>
-                </a:ext>
-              </a:extLst>
-            </p:cNvPr>
-            <p:cNvSpPr txBox="1"/>
-            <p:nvPr/>
-          </p:nvSpPr>
-          <p:spPr>
-            <a:xfrm>
-              <a:off x="3861435" y="1272263"/>
-              <a:ext cx="977265" cy="292388"/>
-            </a:xfrm>
-            <a:prstGeom prst="rect">
-              <a:avLst/>
-            </a:prstGeom>
-            <a:noFill/>
-          </p:spPr>
-          <p:txBody>
-            <a:bodyPr wrap="square" lIns="45720" rIns="45720" anchor="b" anchorCtr="0">
-              <a:noAutofit/>
-            </a:bodyPr>
-            <a:lstStyle/>
-            <a:p>
-              <a:pPr algn="ctr"/>
-              <a:r>
-                <a:rPr lang="ko-KR" altLang="en-US" sz="1600" b="0" dirty="0">
-                  <a:solidFill>
-                    <a:schemeClr val="tx1"/>
-                  </a:solidFill>
-                  <a:latin typeface="Kakao Big Sans" panose="00000500000000000000" pitchFamily="2" charset="0"/>
-                  <a:ea typeface="Kakao Big Sans" panose="00000500000000000000" pitchFamily="2" charset="0"/>
-                </a:rPr>
-                <a:t>송오현</a:t>
-              </a:r>
-              <a:endParaRPr lang="en-US" sz="1600" dirty="0">
+          <a:prstGeom prst="rect">
+            <a:avLst/>
+          </a:prstGeom>
+          <a:noFill/>
+        </p:spPr>
+        <p:txBody>
+          <a:bodyPr wrap="square" lIns="45720" rIns="45720" anchor="b" anchorCtr="0">
+            <a:noAutofit/>
+          </a:bodyPr>
+          <a:lstStyle/>
+          <a:p>
+            <a:pPr algn="ctr"/>
+            <a:r>
+              <a:rPr kumimoji="0" lang="en-US" sz="1600" i="0" u="none" strike="noStrike" kern="1200" cap="none" spc="0" normalizeH="0" baseline="0" noProof="0" dirty="0">
+                <a:ln>
+                  <a:noFill/>
+                </a:ln>
+                <a:solidFill>
+                  <a:prstClr val="black"/>
+                </a:solidFill>
+                <a:effectLst/>
+                <a:uLnTx/>
+                <a:uFillTx/>
+                <a:latin typeface="Segoe UI Semibold" panose="020B0702040204020203" pitchFamily="34" charset="0"/>
+                <a:ea typeface="A little sunshine" pitchFamily="2" charset="0"/>
+                <a:cs typeface="Segoe UI Semibold" panose="020B0702040204020203" pitchFamily="34" charset="0"/>
+              </a:rPr>
+              <a:t>June 2025</a:t>
+            </a:r>
+            <a:endParaRPr lang="en-US" sz="2400" dirty="0">
+              <a:latin typeface="Segoe UI Semibold" panose="020B0702040204020203" pitchFamily="34" charset="0"/>
+              <a:cs typeface="Segoe UI Semibold" panose="020B0702040204020203" pitchFamily="34" charset="0"/>
+            </a:endParaRPr>
+          </a:p>
+        </p:txBody>
+      </p:sp>
+      <p:sp>
+        <p:nvSpPr>
+          <p:cNvPr id="14" name="Korean_Teacher">
+            <a:extLst>
+              <a:ext uri="{FF2B5EF4-FFF2-40B4-BE49-F238E27FC236}">
+                <a16:creationId xmlns:a16="http://schemas.microsoft.com/office/drawing/2014/main" id="{5359B18E-C7E0-FDAE-6A24-F1F6551FDB0F}"/>
+              </a:ext>
+            </a:extLst>
+          </p:cNvPr>
+          <p:cNvSpPr txBox="1"/>
+          <p:nvPr/>
+        </p:nvSpPr>
+        <p:spPr>
+          <a:xfrm>
+            <a:off x="3861435" y="1272263"/>
+            <a:ext cx="977265" cy="292388"/>
+          </a:xfrm>
+          <a:prstGeom prst="rect">
+            <a:avLst/>
+          </a:prstGeom>
+          <a:noFill/>
+        </p:spPr>
+        <p:txBody>
+          <a:bodyPr wrap="square" lIns="45720" rIns="45720" anchor="b" anchorCtr="0">
+            <a:noAutofit/>
+          </a:bodyPr>
+          <a:lstStyle/>
+          <a:p>
+            <a:pPr algn="ctr"/>
+            <a:r>
+              <a:rPr lang="ko-KR" altLang="en-US" sz="1600" b="0" dirty="0">
+                <a:solidFill>
+                  <a:schemeClr val="tx1"/>
+                </a:solidFill>
                 <a:latin typeface="Kakao Big Sans" panose="00000500000000000000" pitchFamily="2" charset="0"/>
                 <a:ea typeface="Kakao Big Sans" panose="00000500000000000000" pitchFamily="2" charset="0"/>
-              </a:endParaRPr>
-            </a:p>
-          </p:txBody>
-        </p:sp>
-        <p:sp>
-          <p:nvSpPr>
-            <p:cNvPr id="6" name="Native_Teacher">
-              <a:extLst>
-                <a:ext uri="{FF2B5EF4-FFF2-40B4-BE49-F238E27FC236}">
-                  <a16:creationId xmlns:a16="http://schemas.microsoft.com/office/drawing/2014/main" id="{33934AC6-4CEA-9AEF-F212-4A4152C6E130}"/>
-                </a:ext>
-              </a:extLst>
-            </p:cNvPr>
-            <p:cNvSpPr txBox="1"/>
-            <p:nvPr/>
-          </p:nvSpPr>
-          <p:spPr>
-            <a:xfrm>
-              <a:off x="1485899" y="1269605"/>
-              <a:ext cx="1216661" cy="365485"/>
-            </a:xfrm>
-            <a:prstGeom prst="rect">
-              <a:avLst/>
-            </a:prstGeom>
-            <a:noFill/>
-          </p:spPr>
-          <p:txBody>
-            <a:bodyPr wrap="square" lIns="45720" rIns="45720" anchor="b" anchorCtr="0">
-              <a:spAutoFit/>
-            </a:bodyPr>
-            <a:lstStyle/>
-            <a:p>
-              <a:pPr algn="ctr">
-                <a:lnSpc>
-                  <a:spcPct val="85000"/>
-                </a:lnSpc>
-              </a:pPr>
-              <a:r>
-                <a:rPr kumimoji="0" lang="en-US" sz="2000" i="0" u="none" strike="noStrike" kern="1200" cap="none" spc="0" normalizeH="0" baseline="0" noProof="0" dirty="0">
-                  <a:ln>
-                    <a:noFill/>
-                  </a:ln>
-                  <a:solidFill>
-                    <a:prstClr val="black"/>
-                  </a:solidFill>
-                  <a:effectLst/>
-                  <a:uLnTx/>
-                  <a:uFillTx/>
-                  <a:latin typeface="Just Another Hand" panose="02000506000000020003" pitchFamily="2" charset="0"/>
-                  <a:ea typeface="A little sunshine" pitchFamily="2" charset="0"/>
-                </a:rPr>
-                <a:t>Aristotle</a:t>
-              </a:r>
-              <a:endParaRPr lang="en-US" sz="3200" dirty="0">
-                <a:latin typeface="Just Another Hand" panose="02000506000000020003" pitchFamily="2" charset="0"/>
-              </a:endParaRPr>
-            </a:p>
-          </p:txBody>
-        </p:sp>
-        <p:sp>
-          <p:nvSpPr>
-            <p:cNvPr id="9" name="Grade_Level">
-              <a:extLst>
-                <a:ext uri="{FF2B5EF4-FFF2-40B4-BE49-F238E27FC236}">
-                  <a16:creationId xmlns:a16="http://schemas.microsoft.com/office/drawing/2014/main" id="{6EBD9C66-9284-1D3E-CF00-9A8077CE630E}"/>
-                </a:ext>
-              </a:extLst>
-            </p:cNvPr>
-            <p:cNvSpPr txBox="1"/>
-            <p:nvPr/>
-          </p:nvSpPr>
-          <p:spPr>
-            <a:xfrm>
-              <a:off x="5372101" y="990600"/>
-              <a:ext cx="1036320" cy="354930"/>
-            </a:xfrm>
-            <a:prstGeom prst="rect">
-              <a:avLst/>
-            </a:prstGeom>
-            <a:noFill/>
-          </p:spPr>
-          <p:txBody>
-            <a:bodyPr wrap="square" lIns="45720" rIns="45720" anchor="b" anchorCtr="0">
-              <a:noAutofit/>
-            </a:bodyPr>
-            <a:lstStyle/>
-            <a:p>
-              <a:pPr algn="ctr"/>
-              <a:r>
-                <a:rPr kumimoji="0" lang="en-US" sz="2000" i="0" u="none" strike="noStrike" kern="1200" cap="none" spc="0" normalizeH="0" baseline="0" noProof="0" dirty="0">
-                  <a:ln>
-                    <a:noFill/>
-                  </a:ln>
-                  <a:solidFill>
-                    <a:prstClr val="black"/>
-                  </a:solidFill>
-                  <a:effectLst/>
-                  <a:uLnTx/>
-                  <a:uFillTx/>
-                  <a:latin typeface="Just Another Hand" panose="02000506000000020003" pitchFamily="2" charset="0"/>
-                  <a:ea typeface="A little sunshine" pitchFamily="2" charset="0"/>
-                </a:rPr>
-                <a:t>E6 Gaia</a:t>
-              </a:r>
-              <a:endParaRPr lang="en-US" sz="3200" dirty="0">
-                <a:latin typeface="Just Another Hand" panose="02000506000000020003" pitchFamily="2" charset="0"/>
-              </a:endParaRPr>
-            </a:p>
-          </p:txBody>
-        </p:sp>
-        <p:sp>
-          <p:nvSpPr>
-            <p:cNvPr id="13" name="Korean_Name">
-              <a:extLst>
-                <a:ext uri="{FF2B5EF4-FFF2-40B4-BE49-F238E27FC236}">
-                  <a16:creationId xmlns:a16="http://schemas.microsoft.com/office/drawing/2014/main" id="{F00BC8B0-E661-32E3-D720-624E8267977F}"/>
-                </a:ext>
-              </a:extLst>
-            </p:cNvPr>
-            <p:cNvSpPr txBox="1"/>
-            <p:nvPr/>
-          </p:nvSpPr>
-          <p:spPr>
-            <a:xfrm>
-              <a:off x="3861435" y="982307"/>
-              <a:ext cx="977265" cy="292388"/>
-            </a:xfrm>
-            <a:prstGeom prst="rect">
-              <a:avLst/>
-            </a:prstGeom>
-            <a:noFill/>
-          </p:spPr>
-          <p:txBody>
-            <a:bodyPr wrap="square" lIns="45720" rIns="45720" anchor="b" anchorCtr="0">
-              <a:noAutofit/>
-            </a:bodyPr>
-            <a:lstStyle/>
-            <a:p>
-              <a:pPr algn="ctr"/>
-              <a:r>
-                <a:rPr kumimoji="0" lang="ko-KR" altLang="en-US" sz="1600" b="0" i="0" u="none" strike="noStrike" kern="1200" cap="none" spc="0" normalizeH="0" baseline="0" noProof="0" dirty="0">
-                  <a:ln>
-                    <a:noFill/>
-                  </a:ln>
-                  <a:solidFill>
-                    <a:prstClr val="black"/>
-                  </a:solidFill>
-                  <a:effectLst/>
-                  <a:uLnTx/>
-                  <a:uFillTx/>
-                  <a:latin typeface="Kakao Big Sans" panose="00000500000000000000" pitchFamily="2" charset="0"/>
-                  <a:ea typeface="Kakao Big Sans" panose="00000500000000000000" pitchFamily="2" charset="0"/>
-                </a:rPr>
-                <a:t>홍길동</a:t>
-              </a:r>
-              <a:endParaRPr lang="en-US" sz="2400" dirty="0">
+              </a:rPr>
+              <a:t>송오현</a:t>
+            </a:r>
+            <a:endParaRPr lang="en-US" sz="1600" dirty="0">
+              <a:latin typeface="Kakao Big Sans" panose="00000500000000000000" pitchFamily="2" charset="0"/>
+              <a:ea typeface="Kakao Big Sans" panose="00000500000000000000" pitchFamily="2" charset="0"/>
+            </a:endParaRPr>
+          </a:p>
+        </p:txBody>
+      </p:sp>
+      <p:sp>
+        <p:nvSpPr>
+          <p:cNvPr id="6" name="Native_Teacher">
+            <a:extLst>
+              <a:ext uri="{FF2B5EF4-FFF2-40B4-BE49-F238E27FC236}">
+                <a16:creationId xmlns:a16="http://schemas.microsoft.com/office/drawing/2014/main" id="{33934AC6-4CEA-9AEF-F212-4A4152C6E130}"/>
+              </a:ext>
+            </a:extLst>
+          </p:cNvPr>
+          <p:cNvSpPr txBox="1"/>
+          <p:nvPr/>
+        </p:nvSpPr>
+        <p:spPr>
+          <a:xfrm>
+            <a:off x="1495424" y="1297177"/>
+            <a:ext cx="1216661" cy="301621"/>
+          </a:xfrm>
+          <a:prstGeom prst="rect">
+            <a:avLst/>
+          </a:prstGeom>
+          <a:noFill/>
+        </p:spPr>
+        <p:txBody>
+          <a:bodyPr wrap="square" lIns="45720" rIns="45720" anchor="b" anchorCtr="0">
+            <a:spAutoFit/>
+          </a:bodyPr>
+          <a:lstStyle/>
+          <a:p>
+            <a:pPr algn="ctr">
+              <a:lnSpc>
+                <a:spcPct val="85000"/>
+              </a:lnSpc>
+            </a:pPr>
+            <a:r>
+              <a:rPr kumimoji="0" lang="en-US" sz="1600" i="0" u="none" strike="noStrike" kern="1200" cap="none" spc="0" normalizeH="0" baseline="0" noProof="0" dirty="0">
+                <a:ln>
+                  <a:noFill/>
+                </a:ln>
+                <a:solidFill>
+                  <a:prstClr val="black"/>
+                </a:solidFill>
+                <a:effectLst/>
+                <a:uLnTx/>
+                <a:uFillTx/>
+                <a:latin typeface="Segoe UI Semibold" panose="020B0702040204020203" pitchFamily="34" charset="0"/>
+                <a:ea typeface="A little sunshine" pitchFamily="2" charset="0"/>
+                <a:cs typeface="Segoe UI Semibold" panose="020B0702040204020203" pitchFamily="34" charset="0"/>
+              </a:rPr>
+              <a:t>Aristotle</a:t>
+            </a:r>
+            <a:endParaRPr lang="en-US" sz="2400" dirty="0">
+              <a:latin typeface="Segoe UI Semibold" panose="020B0702040204020203" pitchFamily="34" charset="0"/>
+              <a:cs typeface="Segoe UI Semibold" panose="020B0702040204020203" pitchFamily="34" charset="0"/>
+            </a:endParaRPr>
+          </a:p>
+        </p:txBody>
+      </p:sp>
+      <p:sp>
+        <p:nvSpPr>
+          <p:cNvPr id="9" name="Grade_Level">
+            <a:extLst>
+              <a:ext uri="{FF2B5EF4-FFF2-40B4-BE49-F238E27FC236}">
+                <a16:creationId xmlns:a16="http://schemas.microsoft.com/office/drawing/2014/main" id="{6EBD9C66-9284-1D3E-CF00-9A8077CE630E}"/>
+              </a:ext>
+            </a:extLst>
+          </p:cNvPr>
+          <p:cNvSpPr txBox="1"/>
+          <p:nvPr/>
+        </p:nvSpPr>
+        <p:spPr>
+          <a:xfrm>
+            <a:off x="5372101" y="974554"/>
+            <a:ext cx="1036320" cy="338328"/>
+          </a:xfrm>
+          <a:prstGeom prst="rect">
+            <a:avLst/>
+          </a:prstGeom>
+          <a:noFill/>
+        </p:spPr>
+        <p:txBody>
+          <a:bodyPr wrap="square" lIns="45720" rIns="45720" anchor="b" anchorCtr="0">
+            <a:noAutofit/>
+          </a:bodyPr>
+          <a:lstStyle/>
+          <a:p>
+            <a:pPr algn="ctr"/>
+            <a:r>
+              <a:rPr kumimoji="0" lang="en-US" sz="1600" i="0" u="none" strike="noStrike" kern="1200" cap="none" spc="0" normalizeH="0" baseline="0" noProof="0" dirty="0">
+                <a:ln>
+                  <a:noFill/>
+                </a:ln>
+                <a:solidFill>
+                  <a:prstClr val="black"/>
+                </a:solidFill>
+                <a:effectLst/>
+                <a:uLnTx/>
+                <a:uFillTx/>
+                <a:latin typeface="Segoe UI Semibold" panose="020B0702040204020203" pitchFamily="34" charset="0"/>
+                <a:ea typeface="A little sunshine" pitchFamily="2" charset="0"/>
+                <a:cs typeface="Segoe UI Semibold" panose="020B0702040204020203" pitchFamily="34" charset="0"/>
+              </a:rPr>
+              <a:t>E6 Gaia</a:t>
+            </a:r>
+            <a:endParaRPr lang="en-US" sz="2400" dirty="0">
+              <a:latin typeface="Segoe UI Semibold" panose="020B0702040204020203" pitchFamily="34" charset="0"/>
+              <a:cs typeface="Segoe UI Semibold" panose="020B0702040204020203" pitchFamily="34" charset="0"/>
+            </a:endParaRPr>
+          </a:p>
+        </p:txBody>
+      </p:sp>
+      <p:sp>
+        <p:nvSpPr>
+          <p:cNvPr id="13" name="Korean_Name">
+            <a:extLst>
+              <a:ext uri="{FF2B5EF4-FFF2-40B4-BE49-F238E27FC236}">
+                <a16:creationId xmlns:a16="http://schemas.microsoft.com/office/drawing/2014/main" id="{F00BC8B0-E661-32E3-D720-624E8267977F}"/>
+              </a:ext>
+            </a:extLst>
+          </p:cNvPr>
+          <p:cNvSpPr txBox="1"/>
+          <p:nvPr/>
+        </p:nvSpPr>
+        <p:spPr>
+          <a:xfrm>
+            <a:off x="3861435" y="982307"/>
+            <a:ext cx="977265" cy="292388"/>
+          </a:xfrm>
+          <a:prstGeom prst="rect">
+            <a:avLst/>
+          </a:prstGeom>
+          <a:noFill/>
+        </p:spPr>
+        <p:txBody>
+          <a:bodyPr wrap="square" lIns="45720" rIns="45720" anchor="b" anchorCtr="0">
+            <a:noAutofit/>
+          </a:bodyPr>
+          <a:lstStyle/>
+          <a:p>
+            <a:pPr algn="ctr"/>
+            <a:r>
+              <a:rPr kumimoji="0" lang="ko-KR" altLang="en-US" sz="1600" b="0" i="0" u="none" strike="noStrike" kern="1200" cap="none" spc="0" normalizeH="0" baseline="0" noProof="0" dirty="0">
+                <a:ln>
+                  <a:noFill/>
+                </a:ln>
+                <a:solidFill>
+                  <a:prstClr val="black"/>
+                </a:solidFill>
+                <a:effectLst/>
+                <a:uLnTx/>
+                <a:uFillTx/>
                 <a:latin typeface="Kakao Big Sans" panose="00000500000000000000" pitchFamily="2" charset="0"/>
                 <a:ea typeface="Kakao Big Sans" panose="00000500000000000000" pitchFamily="2" charset="0"/>
-              </a:endParaRPr>
-            </a:p>
-          </p:txBody>
-        </p:sp>
-        <p:sp>
-          <p:nvSpPr>
-            <p:cNvPr id="5" name="English_Name">
-              <a:extLst>
-                <a:ext uri="{FF2B5EF4-FFF2-40B4-BE49-F238E27FC236}">
-                  <a16:creationId xmlns:a16="http://schemas.microsoft.com/office/drawing/2014/main" id="{9456CAC5-6CD1-0CBF-C271-A5041AC6163F}"/>
-                </a:ext>
-              </a:extLst>
-            </p:cNvPr>
-            <p:cNvSpPr txBox="1"/>
-            <p:nvPr/>
-          </p:nvSpPr>
-          <p:spPr>
-            <a:xfrm>
-              <a:off x="1485899" y="812800"/>
-              <a:ext cx="1216661" cy="508000"/>
-            </a:xfrm>
-            <a:prstGeom prst="rect">
-              <a:avLst/>
-            </a:prstGeom>
-            <a:noFill/>
-          </p:spPr>
-          <p:txBody>
-            <a:bodyPr wrap="none" lIns="45720" rIns="45720" anchor="b" anchorCtr="0">
-              <a:noAutofit/>
-            </a:bodyPr>
-            <a:lstStyle/>
-            <a:p>
-              <a:pPr algn="ctr">
-                <a:lnSpc>
-                  <a:spcPct val="85000"/>
-                </a:lnSpc>
-              </a:pPr>
-              <a:r>
-                <a:rPr kumimoji="0" lang="en-US" sz="2000" i="0" u="none" strike="noStrike" kern="1200" cap="none" spc="0" normalizeH="0" baseline="0" noProof="0" dirty="0" err="1">
-                  <a:ln>
-                    <a:noFill/>
-                  </a:ln>
-                  <a:solidFill>
-                    <a:prstClr val="black"/>
-                  </a:solidFill>
-                  <a:effectLst/>
-                  <a:uLnTx/>
-                  <a:uFillTx/>
-                  <a:latin typeface="Just Another Hand" panose="02000506000000020003" pitchFamily="2" charset="0"/>
-                  <a:ea typeface="A little sunshine" pitchFamily="2" charset="0"/>
-                </a:rPr>
-                <a:t>Gildong</a:t>
-              </a:r>
-              <a:endParaRPr lang="en-US" sz="3200" dirty="0">
-                <a:latin typeface="Just Another Hand" panose="02000506000000020003" pitchFamily="2" charset="0"/>
-              </a:endParaRPr>
-            </a:p>
-          </p:txBody>
-        </p:sp>
-      </p:grpSp>
+              </a:rPr>
+              <a:t>홍길동</a:t>
+            </a:r>
+            <a:endParaRPr lang="en-US" sz="2400" dirty="0">
+              <a:latin typeface="Kakao Big Sans" panose="00000500000000000000" pitchFamily="2" charset="0"/>
+              <a:ea typeface="Kakao Big Sans" panose="00000500000000000000" pitchFamily="2" charset="0"/>
+            </a:endParaRPr>
+          </a:p>
+        </p:txBody>
+      </p:sp>
+      <p:sp>
+        <p:nvSpPr>
+          <p:cNvPr id="5" name="English_Name">
+            <a:extLst>
+              <a:ext uri="{FF2B5EF4-FFF2-40B4-BE49-F238E27FC236}">
+                <a16:creationId xmlns:a16="http://schemas.microsoft.com/office/drawing/2014/main" id="{9456CAC5-6CD1-0CBF-C271-A5041AC6163F}"/>
+              </a:ext>
+            </a:extLst>
+          </p:cNvPr>
+          <p:cNvSpPr txBox="1"/>
+          <p:nvPr/>
+        </p:nvSpPr>
+        <p:spPr>
+          <a:xfrm>
+            <a:off x="1485899" y="974554"/>
+            <a:ext cx="1216661" cy="338493"/>
+          </a:xfrm>
+          <a:prstGeom prst="rect">
+            <a:avLst/>
+          </a:prstGeom>
+          <a:noFill/>
+        </p:spPr>
+        <p:txBody>
+          <a:bodyPr wrap="none" lIns="45720" rIns="45720" anchor="b" anchorCtr="0">
+            <a:noAutofit/>
+          </a:bodyPr>
+          <a:lstStyle/>
+          <a:p>
+            <a:pPr algn="ctr">
+              <a:lnSpc>
+                <a:spcPct val="85000"/>
+              </a:lnSpc>
+            </a:pPr>
+            <a:r>
+              <a:rPr kumimoji="0" lang="en-US" sz="1600" i="0" u="none" strike="noStrike" kern="1200" cap="none" spc="0" normalizeH="0" baseline="0" noProof="0" dirty="0" err="1">
+                <a:ln>
+                  <a:noFill/>
+                </a:ln>
+                <a:solidFill>
+                  <a:prstClr val="black"/>
+                </a:solidFill>
+                <a:effectLst/>
+                <a:uLnTx/>
+                <a:uFillTx/>
+                <a:latin typeface="Segoe UI Semibold" panose="020B0702040204020203" pitchFamily="34" charset="0"/>
+                <a:ea typeface="A little sunshine" pitchFamily="2" charset="0"/>
+                <a:cs typeface="Segoe UI Semibold" panose="020B0702040204020203" pitchFamily="34" charset="0"/>
+              </a:rPr>
+              <a:t>Gildong</a:t>
+            </a:r>
+            <a:endParaRPr lang="en-US" sz="2400" dirty="0">
+              <a:latin typeface="Segoe UI Semibold" panose="020B0702040204020203" pitchFamily="34" charset="0"/>
+              <a:cs typeface="Segoe UI Semibold" panose="020B0702040204020203" pitchFamily="34" charset="0"/>
+            </a:endParaRPr>
+          </a:p>
+        </p:txBody>
+      </p:sp>
     </p:spTree>
     <p:extLst>
       <p:ext uri="{BB962C8B-B14F-4D97-AF65-F5344CB8AC3E}">

</xml_diff>